<commit_message>
One-command demo launcher, demo script, README and deck updated with current numbers
</commit_message>
<xml_diff>
--- a/SIH2026-IDEA-Presentation-HexaBits.pptx
+++ b/SIH2026-IDEA-Presentation-HexaBits.pptx
@@ -12725,7 +12725,7 @@
                 </a:solidFill>
                 <a:latin typeface="Calibri"/>
               </a:rPr>
-              <a:t>4 detectors (DOM, regex with Luhn, NER, BlazeFace) fused; eval harness: 5/5 fields, 0 false positives</a:t>
+              <a:t>DOM + regex (Luhn, Verhoeff) + NER + BlazeFace fused; eval: 100% recall, 91.3% precision</a:t>
             </a:r>
           </a:p>
         </p:txBody>
@@ -12908,7 +12908,7 @@
                 </a:solidFill>
                 <a:latin typeface="Calibri"/>
               </a:rPr>
-              <a:t>Pixel-exact DOM boxes; DOM-safe zones suppress vision false positives</a:t>
+              <a:t>Pixel-exact DOM boxes; eval: 92.8% of masked pixels are sensitive, mean IoU 0.99</a:t>
             </a:r>
           </a:p>
         </p:txBody>
@@ -13091,7 +13091,7 @@
                 </a:solidFill>
                 <a:latin typeface="Calibri"/>
               </a:rPr>
-              <a:t>int8 / fp16 quantized models, loaded lazily in one offscreen document</a:t>
+              <a:t>int8 / fp16 models in one offscreen doc; heap and WebGPU shown live per step</a:t>
             </a:r>
           </a:p>
         </p:txBody>
@@ -13274,7 +13274,7 @@
                 </a:solidFill>
                 <a:latin typeface="Calibri"/>
               </a:rPr>
-              <a:t>DOM-first fast path, WebGPU inference, fusion step under 1 ms</a:t>
+              <a:t>Per-step breakdown shown live: capture, on-device, planner, act</a:t>
             </a:r>
           </a:p>
         </p:txBody>
@@ -18543,7 +18543,7 @@
                 </a:solidFill>
                 <a:latin typeface="Calibri"/>
               </a:rPr>
-              <a:t>Llama 3.2 Vision</a:t>
+              <a:t>Llama 4 Scout (open-weights VLM)</a:t>
             </a:r>
           </a:p>
           <a:p>
@@ -18559,7 +18559,7 @@
                 </a:solidFill>
                 <a:latin typeface="Calibri"/>
               </a:rPr>
-              <a:t>hf.co/meta-llama/Llama-3.2-11B-Vision-Instruct</a:t>
+              <a:t>hf.co/meta-llama/Llama-4-Scout-17B-16E-Instruct</a:t>
             </a:r>
           </a:p>
           <a:p>
@@ -18813,7 +18813,7 @@
                 </a:solidFill>
                 <a:latin typeface="Calibri"/>
               </a:rPr>
-              <a:t>MV3 extension + FastAPI server built and running. Eval (eval/results.md) runs the real redaction code on a labelled fixture: 5/5 sensitive fields redacted, 0/2 false positives, 0 Luhn-invalid card hits, fusion in 0.85 ms.</a:t>
+              <a:t>Extension, server and Jarvis desktop companion built. Eval (eval/results.md) runs the shipping redaction code on 32 labelled items: 100% recall, 91.3% precision, 92.8% pixel precision; text PII 100% / 100% on 25 cases.</a:t>
             </a:r>
           </a:p>
         </p:txBody>

</xml_diff>